<commit_message>
Regenerate trip documents with native styling
Co-authored-by: Copilot App <223556219+Copilot@users.noreply.github.com>

Copilot-Session: 13e0740a-6157-4b9e-a1cf-7ea296fb45ff
</commit_message>
<xml_diff>
--- a/planning-documents/priya-food-and-activity-pitch.pptx
+++ b/planning-documents/priya-food-and-activity-pitch.pptx
@@ -596,7 +596,7 @@
           <a:p>
             <a:r>
               <a:rPr lang="en-US" dirty="0"/>
-              <a:t>if they say no to this, show them the slide with the price later</a:t>
+              <a:t>if people say no, show them this one again</a:t>
             </a:r>
             <a:endParaRPr lang="en-US" dirty="0"/>
           </a:p>
@@ -1391,7 +1391,7 @@
     <p:bg>
       <p:bgPr>
         <a:solidFill>
-          <a:srgbClr val="FDE9F1"/>
+          <a:srgbClr val="FCE8F0"/>
         </a:solidFill>
       </p:bgPr>
     </p:bg>
@@ -1417,8 +1417,8 @@
         </p:nvSpPr>
         <p:spPr>
           <a:xfrm>
-            <a:off x="502920" y="384048"/>
-            <a:ext cx="11064240" cy="658368"/>
+            <a:off x="502920" y="475488"/>
+            <a:ext cx="7772400" cy="640080"/>
           </a:xfrm>
           <a:prstGeom prst="rect">
             <a:avLst/>
@@ -1434,17 +1434,17 @@
               <a:buNone/>
             </a:pPr>
             <a:r>
-              <a:rPr lang="en-US" sz="3000" b="1" dirty="0">
+              <a:rPr lang="en-US" sz="3400" b="1" dirty="0">
                 <a:solidFill>
                   <a:srgbClr val="C2185B"/>
                 </a:solidFill>
-                <a:latin typeface="Aptos Display" pitchFamily="34" charset="0"/>
-                <a:ea typeface="Aptos Display" pitchFamily="34" charset="-122"/>
-                <a:cs typeface="Aptos Display" pitchFamily="34" charset="-120"/>
+                <a:latin typeface="Comic Sans MS" pitchFamily="34" charset="0"/>
+                <a:ea typeface="Comic Sans MS" pitchFamily="34" charset="-122"/>
+                <a:cs typeface="Comic Sans MS" pitchFamily="34" charset="-120"/>
               </a:rPr>
-              <a:t>the pastel de nata agenda 🥐</a:t>
-            </a:r>
-            <a:endParaRPr lang="en-US" sz="3000" dirty="0"/>
+              <a:t>the pastel de nata agenda</a:t>
+            </a:r>
+            <a:endParaRPr lang="en-US" sz="3400" dirty="0"/>
           </a:p>
         </p:txBody>
       </p:sp>
@@ -1456,8 +1456,8 @@
         </p:nvSpPr>
         <p:spPr>
           <a:xfrm>
-            <a:off x="594360" y="1325880"/>
-            <a:ext cx="6400800" cy="365760"/>
+            <a:off x="566928" y="1307592"/>
+            <a:ext cx="5486400" cy="274320"/>
           </a:xfrm>
           <a:prstGeom prst="rect">
             <a:avLst/>
@@ -1466,34 +1466,60 @@
           <a:ln/>
         </p:spPr>
         <p:txBody>
-          <a:bodyPr wrap="square" rtlCol="0" anchor="ctr"/>
+          <a:bodyPr wrap="square" lIns="0" tIns="0" rIns="0" bIns="0" rtlCol="0" anchor="ctr"/>
           <a:lstStyle/>
           <a:p>
             <a:pPr indent="0" marL="0">
               <a:buNone/>
             </a:pPr>
             <a:r>
-              <a:rPr lang="en-US" sz="1900" dirty="0">
+              <a:rPr lang="en-US" sz="1700" dirty="0">
                 <a:solidFill>
                   <a:srgbClr val="7A275A"/>
                 </a:solidFill>
+                <a:latin typeface="Aptos" pitchFamily="34" charset="0"/>
+                <a:ea typeface="Aptos" pitchFamily="34" charset="-122"/>
+                <a:cs typeface="Aptos" pitchFamily="34" charset="-120"/>
               </a:rPr>
-              <a:t>not a spreadsheet. a lifestyle decision.</a:t>
-            </a:r>
-            <a:endParaRPr lang="en-US" sz="1900" dirty="0"/>
-          </a:p>
-        </p:txBody>
-      </p:sp>
-      <p:sp>
-        <p:nvSpPr>
-          <p:cNvPr id="4" name="Text 2"/>
+              <a:t>may 2027 / not a spreadsheet / thank god</a:t>
+            </a:r>
+            <a:endParaRPr lang="en-US" sz="1700" dirty="0"/>
+          </a:p>
+        </p:txBody>
+      </p:sp>
+      <p:pic>
+        <p:nvPicPr>
+          <p:cNvPr id="4" name="Image 0" descr="C:\Users\gusing\.copilot\chats\2026-09-18\ubiquitous-parakeet-7374a405\images-pexels\pastel-de-nata-1.jpg">    </p:cNvPr>
+          <p:cNvPicPr>
+            <a:picLocks noChangeAspect="1"/>
+          </p:cNvPicPr>
+          <p:nvPr/>
+        </p:nvPicPr>
+        <p:blipFill>
+          <a:blip r:embed="rId1"/>
+          <a:srcRect l="0" r="0" t="0" b="0"/>
+          <a:stretch/>
+        </p:blipFill>
+        <p:spPr>
+          <a:xfrm>
+            <a:off x="7178040" y="1280160"/>
+            <a:ext cx="3474720" cy="3474720"/>
+          </a:xfrm>
+          <a:prstGeom prst="rect">
+            <a:avLst/>
+          </a:prstGeom>
+        </p:spPr>
+      </p:pic>
+      <p:sp>
+        <p:nvSpPr>
+          <p:cNvPr id="5" name="Text 2"/>
           <p:cNvSpPr/>
           <p:nvPr/>
         </p:nvSpPr>
         <p:spPr>
           <a:xfrm>
-            <a:off x="594360" y="5943600"/>
-            <a:ext cx="4572000" cy="274320"/>
+            <a:off x="914400" y="4937760"/>
+            <a:ext cx="914400" cy="457200"/>
           </a:xfrm>
           <a:prstGeom prst="rect">
             <a:avLst/>
@@ -1502,21 +1528,24 @@
           <a:ln/>
         </p:spPr>
         <p:txBody>
-          <a:bodyPr wrap="square" rtlCol="0" anchor="ctr"/>
+          <a:bodyPr wrap="square" lIns="0" tIns="0" rIns="0" bIns="0" rtlCol="0" anchor="ctr"/>
           <a:lstStyle/>
           <a:p>
             <a:pPr indent="0" marL="0">
               <a:buNone/>
             </a:pPr>
             <a:r>
-              <a:rPr lang="en-US" sz="1200" dirty="0">
+              <a:rPr lang="en-US" sz="3200" dirty="0">
                 <a:solidFill>
-                  <a:srgbClr val="7A275A"/>
+                  <a:srgbClr val="000000"/>
                 </a:solidFill>
+                <a:latin typeface="Segoe UI Emoji" pitchFamily="34" charset="0"/>
+                <a:ea typeface="Segoe UI Emoji" pitchFamily="34" charset="-122"/>
+                <a:cs typeface="Segoe UI Emoji" pitchFamily="34" charset="-120"/>
               </a:rPr>
-              <a:t>MAY 2027 / 4 adults / zero restraint</a:t>
-            </a:r>
-            <a:endParaRPr lang="en-US" sz="1200" dirty="0"/>
+              <a:t>🥐</a:t>
+            </a:r>
+            <a:endParaRPr lang="en-US" sz="3200" dirty="0"/>
           </a:p>
         </p:txBody>
       </p:sp>
@@ -1560,8 +1589,8 @@
         </p:nvSpPr>
         <p:spPr>
           <a:xfrm>
-            <a:off x="502920" y="384048"/>
-            <a:ext cx="11064240" cy="658368"/>
+            <a:off x="548640" y="420624"/>
+            <a:ext cx="10332720" cy="548640"/>
           </a:xfrm>
           <a:prstGeom prst="rect">
             <a:avLst/>
@@ -1577,9 +1606,9 @@
               <a:buNone/>
             </a:pPr>
             <a:r>
-              <a:rPr lang="en-US" sz="3000" b="1" dirty="0">
+              <a:rPr lang="en-US" sz="2900" b="1" dirty="0">
                 <a:solidFill>
-                  <a:srgbClr val="2B1B3D"/>
+                  <a:srgbClr val="1C3238"/>
                 </a:solidFill>
                 <a:latin typeface="Aptos Display" pitchFamily="34" charset="0"/>
                 <a:ea typeface="Aptos Display" pitchFamily="34" charset="-122"/>
@@ -1587,7 +1616,7 @@
               </a:rPr>
               <a:t>maré baixa is the first-night answer</a:t>
             </a:r>
-            <a:endParaRPr lang="en-US" sz="3000" dirty="0"/>
+            <a:endParaRPr lang="en-US" sz="2900" dirty="0"/>
           </a:p>
         </p:txBody>
       </p:sp>
@@ -1599,8 +1628,8 @@
         </p:nvSpPr>
         <p:spPr>
           <a:xfrm>
-            <a:off x="685800" y="1234440"/>
-            <a:ext cx="5577840" cy="3383280"/>
+            <a:off x="713232" y="1298448"/>
+            <a:ext cx="4023360" cy="3291840"/>
           </a:xfrm>
           <a:prstGeom prst="rect">
             <a:avLst/>
@@ -1609,174 +1638,124 @@
           <a:ln/>
         </p:spPr>
         <p:txBody>
-          <a:bodyPr wrap="square" rtlCol="0" anchor="ctr"/>
-          <a:lstStyle/>
-          <a:p>
-            <a:pPr marL="228600" indent="-228600">
-              <a:buSzPct val="100000"/>
-              <a:buChar char="•"/>
-            </a:pPr>
-            <a:r>
-              <a:rPr lang="en-US" sz="1900" dirty="0">
+          <a:bodyPr wrap="square" lIns="0" tIns="0" rIns="0" bIns="0" rtlCol="0" anchor="ctr"/>
+          <a:lstStyle/>
+          <a:p>
+            <a:pPr indent="0" marL="0">
+              <a:buNone/>
+            </a:pPr>
+            <a:r>
+              <a:rPr lang="en-US" sz="2100" dirty="0">
                 <a:solidFill>
-                  <a:srgbClr val="000000"/>
+                  <a:srgbClr val="405055"/>
                 </a:solidFill>
+                <a:latin typeface="Aptos" pitchFamily="34" charset="0"/>
+                <a:ea typeface="Aptos" pitchFamily="34" charset="-122"/>
+                <a:cs typeface="Aptos" pitchFamily="34" charset="-120"/>
               </a:rPr>
-              <a:t>• Cais do Sodré</a:t>
-            </a:r>
-            <a:endParaRPr lang="en-US" sz="1900" dirty="0"/>
-          </a:p>
-          <a:p>
-            <a:pPr marL="228600" indent="-228600">
-              <a:buSzPct val="100000"/>
-              <a:buChar char="•"/>
-            </a:pPr>
-            <a:r>
-              <a:rPr lang="en-US" sz="1900" dirty="0">
+              <a:t>cais do sodré</a:t>
+            </a:r>
+            <a:endParaRPr lang="en-US" sz="2100" dirty="0"/>
+          </a:p>
+          <a:p>
+            <a:pPr indent="0" marL="0">
+              <a:buNone/>
+            </a:pPr>
+            <a:r>
+              <a:rPr lang="en-US" sz="2100" dirty="0">
                 <a:solidFill>
-                  <a:srgbClr val="000000"/>
+                  <a:srgbClr val="405055"/>
                 </a:solidFill>
+                <a:latin typeface="Aptos" pitchFamily="34" charset="0"/>
+                <a:ea typeface="Aptos" pitchFamily="34" charset="-122"/>
+                <a:cs typeface="Aptos" pitchFamily="34" charset="-120"/>
               </a:rPr>
-              <a:t>• seafood plates</a:t>
-            </a:r>
-            <a:endParaRPr lang="en-US" sz="1900" dirty="0"/>
-          </a:p>
-          <a:p>
-            <a:pPr marL="228600" indent="-228600">
-              <a:buSzPct val="100000"/>
-              <a:buChar char="•"/>
-            </a:pPr>
-            <a:r>
-              <a:rPr lang="en-US" sz="1900" dirty="0">
+              <a:t>seafood plates</a:t>
+            </a:r>
+            <a:endParaRPr lang="en-US" sz="2100" dirty="0"/>
+          </a:p>
+          <a:p>
+            <a:pPr indent="0" marL="0">
+              <a:buNone/>
+            </a:pPr>
+            <a:r>
+              <a:rPr lang="en-US" sz="2100" dirty="0">
                 <a:solidFill>
-                  <a:srgbClr val="000000"/>
+                  <a:srgbClr val="405055"/>
                 </a:solidFill>
+                <a:latin typeface="Aptos" pitchFamily="34" charset="0"/>
+                <a:ea typeface="Aptos" pitchFamily="34" charset="-122"/>
+                <a:cs typeface="Aptos" pitchFamily="34" charset="-120"/>
               </a:rPr>
-              <a:t>• directory says €€€</a:t>
-            </a:r>
-            <a:endParaRPr lang="en-US" sz="1900" dirty="0"/>
-          </a:p>
-          <a:p>
-            <a:pPr marL="228600" indent="-228600">
-              <a:buSzPct val="100000"/>
-              <a:buChar char="•"/>
-            </a:pPr>
-            <a:r>
-              <a:rPr lang="en-US" sz="1900" dirty="0">
+              <a:t>€€€</a:t>
+            </a:r>
+            <a:endParaRPr lang="en-US" sz="2100" dirty="0"/>
+          </a:p>
+          <a:p>
+            <a:pPr indent="0" marL="0">
+              <a:buNone/>
+            </a:pPr>
+            <a:r>
+              <a:rPr lang="en-US" sz="2100" dirty="0">
                 <a:solidFill>
-                  <a:srgbClr val="000000"/>
+                  <a:srgbClr val="405055"/>
                 </a:solidFill>
+                <a:latin typeface="Aptos" pitchFamily="34" charset="0"/>
+                <a:ea typeface="Aptos" pitchFamily="34" charset="-122"/>
+                <a:cs typeface="Aptos" pitchFamily="34" charset="-120"/>
               </a:rPr>
-              <a:t>• i want the arroz de marisco + whatever has too much butter</a:t>
-            </a:r>
-            <a:endParaRPr lang="en-US" sz="1900" dirty="0"/>
-          </a:p>
-          <a:p>
-            <a:pPr marL="228600" indent="-228600">
-              <a:buSzPct val="100000"/>
-              <a:buChar char="•"/>
-            </a:pPr>
-            <a:r>
-              <a:rPr lang="en-US" sz="1900" dirty="0">
+              <a:t>8:30 is the plan i have</a:t>
+            </a:r>
+            <a:endParaRPr lang="en-US" sz="2100" dirty="0"/>
+          </a:p>
+          <a:p>
+            <a:pPr indent="0" marL="0">
+              <a:buNone/>
+            </a:pPr>
+            <a:endParaRPr lang="en-US" sz="2100" dirty="0"/>
+          </a:p>
+          <a:p>
+            <a:pPr indent="0" marL="0">
+              <a:buNone/>
+            </a:pPr>
+            <a:r>
+              <a:rPr lang="en-US" sz="2100" dirty="0">
                 <a:solidFill>
-                  <a:srgbClr val="000000"/>
+                  <a:srgbClr val="405055"/>
                 </a:solidFill>
+                <a:latin typeface="Aptos" pitchFamily="34" charset="0"/>
+                <a:ea typeface="Aptos" pitchFamily="34" charset="-122"/>
+                <a:cs typeface="Aptos" pitchFamily="34" charset="-120"/>
               </a:rPr>
-              <a:t>• reservation at 8:30?? maya has it wrong probably</a:t>
-            </a:r>
-            <a:endParaRPr lang="en-US" sz="1900" dirty="0"/>
-          </a:p>
-        </p:txBody>
-      </p:sp>
-      <p:sp>
-        <p:nvSpPr>
-          <p:cNvPr id="4" name="Shape 2"/>
-          <p:cNvSpPr/>
+              <a:t>arroz de marisco. i rest my case.</a:t>
+            </a:r>
+            <a:endParaRPr lang="en-US" sz="2100" dirty="0"/>
+          </a:p>
+        </p:txBody>
+      </p:sp>
+      <p:pic>
+        <p:nvPicPr>
+          <p:cNvPr id="4" name="Image 0" descr="C:\Users\gusing\.copilot\chats\2026-09-18\ubiquitous-parakeet-7374a405\images-pexels\seafood-platter-1.jpg">    </p:cNvPr>
+          <p:cNvPicPr>
+            <a:picLocks noChangeAspect="1"/>
+          </p:cNvPicPr>
           <p:nvPr/>
-        </p:nvSpPr>
+        </p:nvPicPr>
+        <p:blipFill>
+          <a:blip r:embed="rId1"/>
+          <a:srcRect l="0" r="0" t="0" b="0"/>
+          <a:stretch/>
+        </p:blipFill>
         <p:spPr>
           <a:xfrm>
-            <a:off x="6903720" y="1143000"/>
-            <a:ext cx="4023360" cy="2880360"/>
+            <a:off x="5166360" y="1115568"/>
+            <a:ext cx="5074920" cy="4023360"/>
           </a:xfrm>
           <a:prstGeom prst="rect">
             <a:avLst/>
           </a:prstGeom>
-          <a:solidFill>
-            <a:srgbClr val="F3E3CF"/>
-          </a:solidFill>
-          <a:ln w="12700">
-            <a:solidFill>
-              <a:srgbClr val="C8A67B"/>
-            </a:solidFill>
-            <a:prstDash val="solid"/>
-          </a:ln>
         </p:spPr>
-      </p:sp>
-      <p:sp>
-        <p:nvSpPr>
-          <p:cNvPr id="5" name="Text 3"/>
-          <p:cNvSpPr/>
-          <p:nvPr/>
-        </p:nvSpPr>
-        <p:spPr>
-          <a:xfrm>
-            <a:off x="7132320" y="1993392"/>
-            <a:ext cx="3566160" cy="640080"/>
-          </a:xfrm>
-          <a:prstGeom prst="rect">
-            <a:avLst/>
-          </a:prstGeom>
-          <a:noFill/>
-          <a:ln/>
-        </p:spPr>
-        <p:txBody>
-          <a:bodyPr wrap="square" rtlCol="0" anchor="ctr"/>
-          <a:lstStyle/>
-          <a:p>
-            <a:pPr algn="ctr" indent="0" marL="0">
-              <a:buNone/>
-            </a:pPr>
-            <a:r>
-              <a:rPr lang="en-US" sz="1600" dirty="0">
-                <a:solidFill>
-                  <a:srgbClr val="765438"/>
-                </a:solidFill>
-              </a:rPr>
-              <a:t>[screenshot placeholder]</a:t>
-            </a:r>
-            <a:endParaRPr lang="en-US" sz="1600" dirty="0"/>
-          </a:p>
-          <a:p>
-            <a:pPr algn="ctr" indent="0" marL="0">
-              <a:buNone/>
-            </a:pPr>
-            <a:r>
-              <a:rPr lang="en-US" sz="1600" dirty="0">
-                <a:solidFill>
-                  <a:srgbClr val="765438"/>
-                </a:solidFill>
-              </a:rPr>
-              <a:t>Mesa Lisboa Index / listing 014</a:t>
-            </a:r>
-            <a:endParaRPr lang="en-US" sz="1600" dirty="0"/>
-          </a:p>
-          <a:p>
-            <a:pPr algn="ctr" indent="0" marL="0">
-              <a:buNone/>
-            </a:pPr>
-            <a:r>
-              <a:rPr lang="en-US" sz="1600" dirty="0">
-                <a:solidFill>
-                  <a:srgbClr val="765438"/>
-                </a:solidFill>
-              </a:rPr>
-              <a:t>Maré Baixa</a:t>
-            </a:r>
-            <a:endParaRPr lang="en-US" sz="1600" dirty="0"/>
-          </a:p>
-        </p:txBody>
-      </p:sp>
+      </p:pic>
     </p:spTree>
   </p:cSld>
   <p:clrMapOvr>
@@ -1817,8 +1796,8 @@
         </p:nvSpPr>
         <p:spPr>
           <a:xfrm>
-            <a:off x="502920" y="384048"/>
-            <a:ext cx="11064240" cy="658368"/>
+            <a:off x="502920" y="502920"/>
+            <a:ext cx="10332720" cy="640080"/>
           </a:xfrm>
           <a:prstGeom prst="rect">
             <a:avLst/>
@@ -1830,7 +1809,7 @@
           <a:bodyPr wrap="square" lIns="0" tIns="0" rIns="0" bIns="0" rtlCol="0" anchor="ctr"/>
           <a:lstStyle/>
           <a:p>
-            <a:pPr indent="0" marL="0">
+            <a:pPr algn="ctr" indent="0" marL="0">
               <a:buNone/>
             </a:pPr>
             <a:r>
@@ -1848,16 +1827,39 @@
           </a:p>
         </p:txBody>
       </p:sp>
-      <p:sp>
-        <p:nvSpPr>
-          <p:cNvPr id="3" name="Text 1"/>
+      <p:pic>
+        <p:nvPicPr>
+          <p:cNvPr id="3" name="Image 0" descr="C:\Users\gusing\.copilot\chats\2026-09-18\ubiquitous-parakeet-7374a405\images-pexels\castle-sintra-portugal-1.jpg">    </p:cNvPr>
+          <p:cNvPicPr>
+            <a:picLocks noChangeAspect="1"/>
+          </p:cNvPicPr>
+          <p:nvPr/>
+        </p:nvPicPr>
+        <p:blipFill>
+          <a:blip r:embed="rId1"/>
+          <a:srcRect l="0" r="0" t="0" b="0"/>
+          <a:stretch/>
+        </p:blipFill>
+        <p:spPr>
+          <a:xfrm>
+            <a:off x="749808" y="1417320"/>
+            <a:ext cx="4023360" cy="3383280"/>
+          </a:xfrm>
+          <a:prstGeom prst="rect">
+            <a:avLst/>
+          </a:prstGeom>
+        </p:spPr>
+      </p:pic>
+      <p:sp>
+        <p:nvSpPr>
+          <p:cNvPr id="4" name="Text 1"/>
           <p:cNvSpPr/>
           <p:nvPr/>
         </p:nvSpPr>
         <p:spPr>
           <a:xfrm>
-            <a:off x="777240" y="1417320"/>
-            <a:ext cx="9692640" cy="1280160"/>
+            <a:off x="5623560" y="1572768"/>
+            <a:ext cx="4389120" cy="2377440"/>
           </a:xfrm>
           <a:prstGeom prst="rect">
             <a:avLst/>
@@ -1866,71 +1868,98 @@
           <a:ln/>
         </p:spPr>
         <p:txBody>
-          <a:bodyPr wrap="square" rtlCol="0" anchor="ctr"/>
-          <a:lstStyle/>
-          <a:p>
-            <a:pPr algn="ctr" indent="0" marL="0">
-              <a:buNone/>
-            </a:pPr>
-            <a:r>
-              <a:rPr lang="en-US" sz="2600" b="1" dirty="0">
+          <a:bodyPr wrap="square" lIns="0" tIns="0" rIns="0" bIns="0" rtlCol="0" anchor="ctr"/>
+          <a:lstStyle/>
+          <a:p>
+            <a:pPr indent="0" marL="0">
+              <a:buNone/>
+            </a:pPr>
+            <a:r>
+              <a:rPr lang="en-US" sz="2500" b="1" dirty="0">
                 <a:solidFill>
                   <a:srgbClr val="003B5C"/>
                 </a:solidFill>
+                <a:latin typeface="Bahnschrift" pitchFamily="34" charset="0"/>
+                <a:ea typeface="Bahnschrift" pitchFamily="34" charset="-122"/>
+                <a:cs typeface="Bahnschrift" pitchFamily="34" charset="-120"/>
               </a:rPr>
-              <a:t>because we have ONE actual group day in Sintra booked.</a:t>
-            </a:r>
-            <a:endParaRPr lang="en-US" sz="2600" dirty="0"/>
-          </a:p>
-          <a:p>
-            <a:pPr algn="ctr" indent="0" marL="0">
-              <a:buNone/>
-            </a:pPr>
-            <a:r>
-              <a:rPr lang="en-US" sz="2600" b="1" dirty="0">
+              <a:t>Rota Curta</a:t>
+            </a:r>
+            <a:endParaRPr lang="en-US" sz="2500" dirty="0"/>
+          </a:p>
+          <a:p>
+            <a:pPr indent="0" marL="0">
+              <a:buNone/>
+            </a:pPr>
+            <a:r>
+              <a:rPr lang="en-US" sz="2500" b="1" dirty="0">
                 <a:solidFill>
                   <a:srgbClr val="003B5C"/>
                 </a:solidFill>
+                <a:latin typeface="Bahnschrift" pitchFamily="34" charset="0"/>
+                <a:ea typeface="Bahnschrift" pitchFamily="34" charset="-122"/>
+                <a:cs typeface="Bahnschrift" pitchFamily="34" charset="-120"/>
               </a:rPr>
-              <a:t>he can find a wave on sunday. probably.</a:t>
-            </a:r>
-            <a:endParaRPr lang="en-US" sz="2600" dirty="0"/>
-          </a:p>
-        </p:txBody>
-      </p:sp>
-      <p:sp>
-        <p:nvSpPr>
-          <p:cNvPr id="4" name="Text 2"/>
-          <p:cNvSpPr/>
-          <p:nvPr/>
-        </p:nvSpPr>
-        <p:spPr>
-          <a:xfrm>
-            <a:off x="1143000" y="4023360"/>
-            <a:ext cx="9235440" cy="457200"/>
-          </a:xfrm>
-          <a:prstGeom prst="rect">
-            <a:avLst/>
-          </a:prstGeom>
-          <a:noFill/>
-          <a:ln/>
-        </p:spPr>
-        <p:txBody>
-          <a:bodyPr wrap="square" rtlCol="0" anchor="ctr"/>
-          <a:lstStyle/>
-          <a:p>
-            <a:pPr algn="ctr" indent="0" marL="0">
-              <a:buNone/>
-            </a:pPr>
-            <a:r>
-              <a:rPr lang="en-US" sz="1700" dirty="0">
+              <a:t>Sintra Palaces</a:t>
+            </a:r>
+            <a:endParaRPr lang="en-US" sz="2500" dirty="0"/>
+          </a:p>
+          <a:p>
+            <a:pPr indent="0" marL="0">
+              <a:buNone/>
+            </a:pPr>
+            <a:r>
+              <a:rPr lang="en-US" sz="2500" b="1" dirty="0">
                 <a:solidFill>
-                  <a:srgbClr val="005B82"/>
+                  <a:srgbClr val="003B5C"/>
                 </a:solidFill>
+                <a:latin typeface="Bahnschrift" pitchFamily="34" charset="0"/>
+                <a:ea typeface="Bahnschrift" pitchFamily="34" charset="-122"/>
+                <a:cs typeface="Bahnschrift" pitchFamily="34" charset="-120"/>
               </a:rPr>
-              <a:t>Rota Curta Excursões / Sintra Palaces / 08:02 / €79 each / palaces included</a:t>
-            </a:r>
-            <a:endParaRPr lang="en-US" sz="1700" dirty="0"/>
+              <a:t>08:02</a:t>
+            </a:r>
+            <a:endParaRPr lang="en-US" sz="2500" dirty="0"/>
+          </a:p>
+          <a:p>
+            <a:pPr indent="0" marL="0">
+              <a:buNone/>
+            </a:pPr>
+            <a:r>
+              <a:rPr lang="en-US" sz="2500" b="1" dirty="0">
+                <a:solidFill>
+                  <a:srgbClr val="003B5C"/>
+                </a:solidFill>
+                <a:latin typeface="Bahnschrift" pitchFamily="34" charset="0"/>
+                <a:ea typeface="Bahnschrift" pitchFamily="34" charset="-122"/>
+                <a:cs typeface="Bahnschrift" pitchFamily="34" charset="-120"/>
+              </a:rPr>
+              <a:t>€79 each</a:t>
+            </a:r>
+            <a:endParaRPr lang="en-US" sz="2500" dirty="0"/>
+          </a:p>
+          <a:p>
+            <a:pPr indent="0" marL="0">
+              <a:buNone/>
+            </a:pPr>
+            <a:endParaRPr lang="en-US" sz="2500" dirty="0"/>
+          </a:p>
+          <a:p>
+            <a:pPr indent="0" marL="0">
+              <a:buNone/>
+            </a:pPr>
+            <a:r>
+              <a:rPr lang="en-US" sz="2500" b="1" dirty="0">
+                <a:solidFill>
+                  <a:srgbClr val="003B5C"/>
+                </a:solidFill>
+                <a:latin typeface="Bahnschrift" pitchFamily="34" charset="0"/>
+                <a:ea typeface="Bahnschrift" pitchFamily="34" charset="-122"/>
+                <a:cs typeface="Bahnschrift" pitchFamily="34" charset="-120"/>
+              </a:rPr>
+              <a:t>we are already booked.</a:t>
+            </a:r>
+            <a:endParaRPr lang="en-US" sz="2500" dirty="0"/>
           </a:p>
         </p:txBody>
       </p:sp>
@@ -1974,8 +2003,8 @@
         </p:nvSpPr>
         <p:spPr>
           <a:xfrm>
-            <a:off x="502920" y="384048"/>
-            <a:ext cx="11064240" cy="658368"/>
+            <a:off x="502920" y="438912"/>
+            <a:ext cx="10058400" cy="548640"/>
           </a:xfrm>
           <a:prstGeom prst="rect">
             <a:avLst/>
@@ -1991,55 +2020,53 @@
               <a:buNone/>
             </a:pPr>
             <a:r>
-              <a:rPr lang="en-US" sz="3000" b="1" dirty="0">
+              <a:rPr lang="en-US" sz="2700" b="1" dirty="0">
                 <a:solidFill>
-                  <a:srgbClr val="2B1B3D"/>
+                  <a:srgbClr val="594F45"/>
                 </a:solidFill>
-                <a:latin typeface="Aptos Display" pitchFamily="34" charset="0"/>
-                <a:ea typeface="Aptos Display" pitchFamily="34" charset="-122"/>
-                <a:cs typeface="Aptos Display" pitchFamily="34" charset="-120"/>
+                <a:latin typeface="Georgia" pitchFamily="34" charset="0"/>
+                <a:ea typeface="Georgia" pitchFamily="34" charset="-122"/>
+                <a:cs typeface="Georgia" pitchFamily="34" charset="-120"/>
               </a:rPr>
               <a:t>photo grid i need us to respect</a:t>
             </a:r>
-            <a:endParaRPr lang="en-US" sz="3000" dirty="0"/>
-          </a:p>
-        </p:txBody>
-      </p:sp>
-      <p:sp>
-        <p:nvSpPr>
-          <p:cNvPr id="3" name="Shape 1"/>
-          <p:cNvSpPr/>
+            <a:endParaRPr lang="en-US" sz="2700" dirty="0"/>
+          </a:p>
+        </p:txBody>
+      </p:sp>
+      <p:pic>
+        <p:nvPicPr>
+          <p:cNvPr id="3" name="Image 0" descr="C:\Users\gusing\.copilot\chats\2026-09-18\ubiquitous-parakeet-7374a405\images-pexels\alfama-street-1.jpg">    </p:cNvPr>
+          <p:cNvPicPr>
+            <a:picLocks noChangeAspect="1"/>
+          </p:cNvPicPr>
           <p:nvPr/>
-        </p:nvSpPr>
+        </p:nvPicPr>
+        <p:blipFill>
+          <a:blip r:embed="rId1"/>
+          <a:srcRect l="0" r="0" t="0" b="0"/>
+          <a:stretch/>
+        </p:blipFill>
         <p:spPr>
           <a:xfrm>
-            <a:off x="640080" y="1188720"/>
-            <a:ext cx="2926080" cy="3108960"/>
+            <a:off x="658368" y="1261872"/>
+            <a:ext cx="2926080" cy="3273552"/>
           </a:xfrm>
           <a:prstGeom prst="rect">
             <a:avLst/>
           </a:prstGeom>
-          <a:solidFill>
-            <a:srgbClr val="DED6C5"/>
-          </a:solidFill>
-          <a:ln w="12700">
-            <a:solidFill>
-              <a:srgbClr val="8B8173"/>
-            </a:solidFill>
-            <a:prstDash val="solid"/>
-          </a:ln>
         </p:spPr>
-      </p:sp>
-      <p:sp>
-        <p:nvSpPr>
-          <p:cNvPr id="4" name="Text 2"/>
+      </p:pic>
+      <p:sp>
+        <p:nvSpPr>
+          <p:cNvPr id="4" name="Text 1"/>
           <p:cNvSpPr/>
           <p:nvPr/>
         </p:nvSpPr>
         <p:spPr>
           <a:xfrm>
-            <a:off x="868680" y="2432304"/>
-            <a:ext cx="2468880" cy="530352"/>
+            <a:off x="658368" y="4617720"/>
+            <a:ext cx="2926080" cy="274320"/>
           </a:xfrm>
           <a:prstGeom prst="rect">
             <a:avLst/>
@@ -2048,87 +2075,60 @@
           <a:ln/>
         </p:spPr>
         <p:txBody>
-          <a:bodyPr wrap="square" rtlCol="0" anchor="ctr"/>
+          <a:bodyPr wrap="square" lIns="0" tIns="0" rIns="0" bIns="0" rtlCol="0" anchor="ctr"/>
           <a:lstStyle/>
           <a:p>
             <a:pPr algn="ctr" indent="0" marL="0">
               <a:buNone/>
             </a:pPr>
             <a:r>
-              <a:rPr lang="en-US" sz="1500" dirty="0">
+              <a:rPr lang="en-US" sz="1300" dirty="0">
                 <a:solidFill>
                   <a:srgbClr val="594F45"/>
                 </a:solidFill>
-              </a:rPr>
-              <a:t>[screenshot placeholder]</a:t>
-            </a:r>
-            <a:endParaRPr lang="en-US" sz="1500" dirty="0"/>
-          </a:p>
-          <a:p>
-            <a:pPr algn="ctr" indent="0" marL="0">
-              <a:buNone/>
-            </a:pPr>
-            <a:r>
-              <a:rPr lang="en-US" sz="1500" dirty="0">
-                <a:solidFill>
-                  <a:srgbClr val="594F45"/>
-                </a:solidFill>
+                <a:latin typeface="Aptos" pitchFamily="34" charset="0"/>
+                <a:ea typeface="Aptos" pitchFamily="34" charset="-122"/>
+                <a:cs typeface="Aptos" pitchFamily="34" charset="-120"/>
               </a:rPr>
               <a:t>alfama stairs</a:t>
             </a:r>
-            <a:endParaRPr lang="en-US" sz="1500" dirty="0"/>
-          </a:p>
-          <a:p>
-            <a:pPr algn="ctr" indent="0" marL="0">
-              <a:buNone/>
-            </a:pPr>
-            <a:r>
-              <a:rPr lang="en-US" sz="1500" dirty="0">
-                <a:solidFill>
-                  <a:srgbClr val="594F45"/>
-                </a:solidFill>
-              </a:rPr>
-              <a:t>source: Lisbon Atlas</a:t>
-            </a:r>
-            <a:endParaRPr lang="en-US" sz="1500" dirty="0"/>
-          </a:p>
-        </p:txBody>
-      </p:sp>
-      <p:sp>
-        <p:nvSpPr>
-          <p:cNvPr id="5" name="Shape 3"/>
-          <p:cNvSpPr/>
+            <a:endParaRPr lang="en-US" sz="1300" dirty="0"/>
+          </a:p>
+        </p:txBody>
+      </p:sp>
+      <p:pic>
+        <p:nvPicPr>
+          <p:cNvPr id="5" name="Image 1" descr="C:\Users\gusing\.copilot\chats\2026-09-18\ubiquitous-parakeet-7374a405\images-pexels\pastel-de-nata-1.jpg">    </p:cNvPr>
+          <p:cNvPicPr>
+            <a:picLocks noChangeAspect="1"/>
+          </p:cNvPicPr>
           <p:nvPr/>
-        </p:nvSpPr>
+        </p:nvPicPr>
+        <p:blipFill>
+          <a:blip r:embed="rId2"/>
+          <a:srcRect l="0" r="0" t="0" b="0"/>
+          <a:stretch/>
+        </p:blipFill>
         <p:spPr>
           <a:xfrm>
-            <a:off x="4160520" y="1188720"/>
-            <a:ext cx="2926080" cy="3108960"/>
+            <a:off x="4160520" y="1261872"/>
+            <a:ext cx="2926080" cy="3273552"/>
           </a:xfrm>
           <a:prstGeom prst="rect">
             <a:avLst/>
           </a:prstGeom>
-          <a:solidFill>
-            <a:srgbClr val="FFD1DC"/>
-          </a:solidFill>
-          <a:ln w="12700">
-            <a:solidFill>
-              <a:srgbClr val="8B8173"/>
-            </a:solidFill>
-            <a:prstDash val="solid"/>
-          </a:ln>
         </p:spPr>
-      </p:sp>
-      <p:sp>
-        <p:nvSpPr>
-          <p:cNvPr id="6" name="Text 4"/>
+      </p:pic>
+      <p:sp>
+        <p:nvSpPr>
+          <p:cNvPr id="6" name="Text 2"/>
           <p:cNvSpPr/>
           <p:nvPr/>
         </p:nvSpPr>
         <p:spPr>
           <a:xfrm>
-            <a:off x="4389120" y="2432304"/>
-            <a:ext cx="2468880" cy="530352"/>
+            <a:off x="4160520" y="4617720"/>
+            <a:ext cx="2926080" cy="274320"/>
           </a:xfrm>
           <a:prstGeom prst="rect">
             <a:avLst/>
@@ -2137,87 +2137,60 @@
           <a:ln/>
         </p:spPr>
         <p:txBody>
-          <a:bodyPr wrap="square" rtlCol="0" anchor="ctr"/>
+          <a:bodyPr wrap="square" lIns="0" tIns="0" rIns="0" bIns="0" rtlCol="0" anchor="ctr"/>
           <a:lstStyle/>
           <a:p>
             <a:pPr algn="ctr" indent="0" marL="0">
               <a:buNone/>
             </a:pPr>
             <a:r>
-              <a:rPr lang="en-US" sz="1500" dirty="0">
+              <a:rPr lang="en-US" sz="1300" dirty="0">
                 <a:solidFill>
                   <a:srgbClr val="594F45"/>
                 </a:solidFill>
-              </a:rPr>
-              <a:t>[screenshot placeholder]</a:t>
-            </a:r>
-            <a:endParaRPr lang="en-US" sz="1500" dirty="0"/>
-          </a:p>
-          <a:p>
-            <a:pPr algn="ctr" indent="0" marL="0">
-              <a:buNone/>
-            </a:pPr>
-            <a:r>
-              <a:rPr lang="en-US" sz="1500" dirty="0">
-                <a:solidFill>
-                  <a:srgbClr val="594F45"/>
-                </a:solidFill>
+                <a:latin typeface="Aptos" pitchFamily="34" charset="0"/>
+                <a:ea typeface="Aptos" pitchFamily="34" charset="-122"/>
+                <a:cs typeface="Aptos" pitchFamily="34" charset="-120"/>
               </a:rPr>
               <a:t>pastel + coffee</a:t>
             </a:r>
-            <a:endParaRPr lang="en-US" sz="1500" dirty="0"/>
-          </a:p>
-          <a:p>
-            <a:pPr algn="ctr" indent="0" marL="0">
-              <a:buNone/>
-            </a:pPr>
-            <a:r>
-              <a:rPr lang="en-US" sz="1500" dirty="0">
-                <a:solidFill>
-                  <a:srgbClr val="594F45"/>
-                </a:solidFill>
-              </a:rPr>
-              <a:t>source: Lisbon Atlas</a:t>
-            </a:r>
-            <a:endParaRPr lang="en-US" sz="1500" dirty="0"/>
-          </a:p>
-        </p:txBody>
-      </p:sp>
-      <p:sp>
-        <p:nvSpPr>
-          <p:cNvPr id="7" name="Shape 5"/>
-          <p:cNvSpPr/>
+            <a:endParaRPr lang="en-US" sz="1300" dirty="0"/>
+          </a:p>
+        </p:txBody>
+      </p:sp>
+      <p:pic>
+        <p:nvPicPr>
+          <p:cNvPr id="7" name="Image 2" descr="C:\Users\gusing\.copilot\chats\2026-09-18\ubiquitous-parakeet-7374a405\images-pexels\castle-sintra-portugal-4.jpg">    </p:cNvPr>
+          <p:cNvPicPr>
+            <a:picLocks noChangeAspect="1"/>
+          </p:cNvPicPr>
           <p:nvPr/>
-        </p:nvSpPr>
+        </p:nvPicPr>
+        <p:blipFill>
+          <a:blip r:embed="rId3"/>
+          <a:srcRect l="0" r="0" t="0" b="0"/>
+          <a:stretch/>
+        </p:blipFill>
         <p:spPr>
           <a:xfrm>
-            <a:off x="7680960" y="1188720"/>
-            <a:ext cx="2926080" cy="3108960"/>
+            <a:off x="7662672" y="1261872"/>
+            <a:ext cx="2926080" cy="3273552"/>
           </a:xfrm>
           <a:prstGeom prst="rect">
             <a:avLst/>
           </a:prstGeom>
-          <a:solidFill>
-            <a:srgbClr val="DED6C5"/>
-          </a:solidFill>
-          <a:ln w="12700">
-            <a:solidFill>
-              <a:srgbClr val="8B8173"/>
-            </a:solidFill>
-            <a:prstDash val="solid"/>
-          </a:ln>
         </p:spPr>
-      </p:sp>
-      <p:sp>
-        <p:nvSpPr>
-          <p:cNvPr id="8" name="Text 6"/>
+      </p:pic>
+      <p:sp>
+        <p:nvSpPr>
+          <p:cNvPr id="8" name="Text 3"/>
           <p:cNvSpPr/>
           <p:nvPr/>
         </p:nvSpPr>
         <p:spPr>
           <a:xfrm>
-            <a:off x="7909560" y="2432304"/>
-            <a:ext cx="2468880" cy="530352"/>
+            <a:off x="7662672" y="4617720"/>
+            <a:ext cx="2926080" cy="274320"/>
           </a:xfrm>
           <a:prstGeom prst="rect">
             <a:avLst/>
@@ -2226,85 +2199,24 @@
           <a:ln/>
         </p:spPr>
         <p:txBody>
-          <a:bodyPr wrap="square" rtlCol="0" anchor="ctr"/>
+          <a:bodyPr wrap="square" lIns="0" tIns="0" rIns="0" bIns="0" rtlCol="0" anchor="ctr"/>
           <a:lstStyle/>
           <a:p>
             <a:pPr algn="ctr" indent="0" marL="0">
               <a:buNone/>
             </a:pPr>
             <a:r>
-              <a:rPr lang="en-US" sz="1500" dirty="0">
+              <a:rPr lang="en-US" sz="1300" dirty="0">
                 <a:solidFill>
                   <a:srgbClr val="594F45"/>
                 </a:solidFill>
-              </a:rPr>
-              <a:t>[screenshot placeholder]</a:t>
-            </a:r>
-            <a:endParaRPr lang="en-US" sz="1500" dirty="0"/>
-          </a:p>
-          <a:p>
-            <a:pPr algn="ctr" indent="0" marL="0">
-              <a:buNone/>
-            </a:pPr>
-            <a:r>
-              <a:rPr lang="en-US" sz="1500" dirty="0">
-                <a:solidFill>
-                  <a:srgbClr val="594F45"/>
-                </a:solidFill>
+                <a:latin typeface="Aptos" pitchFamily="34" charset="0"/>
+                <a:ea typeface="Aptos" pitchFamily="34" charset="-122"/>
+                <a:cs typeface="Aptos" pitchFamily="34" charset="-120"/>
               </a:rPr>
               <a:t>sintra fog</a:t>
             </a:r>
-            <a:endParaRPr lang="en-US" sz="1500" dirty="0"/>
-          </a:p>
-          <a:p>
-            <a:pPr algn="ctr" indent="0" marL="0">
-              <a:buNone/>
-            </a:pPr>
-            <a:r>
-              <a:rPr lang="en-US" sz="1500" dirty="0">
-                <a:solidFill>
-                  <a:srgbClr val="594F45"/>
-                </a:solidFill>
-              </a:rPr>
-              <a:t>source: Lisbon Atlas</a:t>
-            </a:r>
-            <a:endParaRPr lang="en-US" sz="1500" dirty="0"/>
-          </a:p>
-        </p:txBody>
-      </p:sp>
-      <p:sp>
-        <p:nvSpPr>
-          <p:cNvPr id="9" name="Text 7"/>
-          <p:cNvSpPr/>
-          <p:nvPr/>
-        </p:nvSpPr>
-        <p:spPr>
-          <a:xfrm>
-            <a:off x="658368" y="4892040"/>
-            <a:ext cx="6766560" cy="274320"/>
-          </a:xfrm>
-          <a:prstGeom prst="rect">
-            <a:avLst/>
-          </a:prstGeom>
-          <a:noFill/>
-          <a:ln/>
-        </p:spPr>
-        <p:txBody>
-          <a:bodyPr wrap="square" rtlCol="0" anchor="ctr"/>
-          <a:lstStyle/>
-          <a:p>
-            <a:pPr indent="0" marL="0">
-              <a:buNone/>
-            </a:pPr>
-            <a:r>
-              <a:rPr lang="en-US" sz="1500" dirty="0">
-                <a:solidFill>
-                  <a:srgbClr val="594F45"/>
-                </a:solidFill>
-              </a:rPr>
-              <a:t>also no one wears all black in every photo please</a:t>
-            </a:r>
-            <a:endParaRPr lang="en-US" sz="1500" dirty="0"/>
+            <a:endParaRPr lang="en-US" sz="1300" dirty="0"/>
           </a:p>
         </p:txBody>
       </p:sp>
@@ -2348,8 +2260,8 @@
         </p:nvSpPr>
         <p:spPr>
           <a:xfrm>
-            <a:off x="502920" y="384048"/>
-            <a:ext cx="11064240" cy="658368"/>
+            <a:off x="914400" y="2148840"/>
+            <a:ext cx="9144000" cy="822960"/>
           </a:xfrm>
           <a:prstGeom prst="rect">
             <a:avLst/>
@@ -2361,21 +2273,21 @@
           <a:bodyPr wrap="square" lIns="0" tIns="0" rIns="0" bIns="0" rtlCol="0" anchor="ctr"/>
           <a:lstStyle/>
           <a:p>
-            <a:pPr indent="0" marL="0">
-              <a:buNone/>
-            </a:pPr>
-            <a:r>
-              <a:rPr lang="en-US" sz="3000" b="1" dirty="0">
+            <a:pPr algn="ctr" indent="0" marL="0">
+              <a:buNone/>
+            </a:pPr>
+            <a:r>
+              <a:rPr lang="en-US" sz="4200" b="1" dirty="0">
                 <a:solidFill>
                   <a:srgbClr val="FFDE59"/>
                 </a:solidFill>
-                <a:latin typeface="Aptos Display" pitchFamily="34" charset="0"/>
-                <a:ea typeface="Aptos Display" pitchFamily="34" charset="-122"/>
-                <a:cs typeface="Aptos Display" pitchFamily="34" charset="-120"/>
+                <a:latin typeface="Comic Sans MS" pitchFamily="34" charset="0"/>
+                <a:ea typeface="Comic Sans MS" pitchFamily="34" charset="-122"/>
+                <a:cs typeface="Comic Sans MS" pitchFamily="34" charset="-120"/>
               </a:rPr>
-              <a:t>counterpoint: maybe surf day</a:t>
-            </a:r>
-            <a:endParaRPr lang="en-US" sz="3000" dirty="0"/>
+              <a:t>fine. maybe surf day.</a:t>
+            </a:r>
+            <a:endParaRPr lang="en-US" sz="4200" dirty="0"/>
           </a:p>
         </p:txBody>
       </p:sp>
@@ -2387,8 +2299,8 @@
         </p:nvSpPr>
         <p:spPr>
           <a:xfrm>
-            <a:off x="3657600" y="2423160"/>
-            <a:ext cx="4937760" cy="731520"/>
+            <a:off x="2011680" y="3675888"/>
+            <a:ext cx="6858000" cy="274320"/>
           </a:xfrm>
           <a:prstGeom prst="rect">
             <a:avLst/>
@@ -2397,57 +2309,24 @@
           <a:ln/>
         </p:spPr>
         <p:txBody>
-          <a:bodyPr wrap="square" rtlCol="0" anchor="ctr"/>
+          <a:bodyPr wrap="square" lIns="0" tIns="0" rIns="0" bIns="0" rtlCol="0" anchor="ctr"/>
           <a:lstStyle/>
           <a:p>
             <a:pPr algn="ctr" indent="0" marL="0">
               <a:buNone/>
             </a:pPr>
             <a:r>
-              <a:rPr lang="en-US" sz="4400" b="1" dirty="0">
+              <a:rPr lang="en-US" sz="1800" dirty="0">
                 <a:solidFill>
                   <a:srgbClr val="FFFFFF"/>
                 </a:solidFill>
+                <a:latin typeface="Aptos" pitchFamily="34" charset="0"/>
+                <a:ea typeface="Aptos" pitchFamily="34" charset="-122"/>
+                <a:cs typeface="Aptos" pitchFamily="34" charset="-120"/>
               </a:rPr>
-              <a:t>fine. MAYBE.</a:t>
-            </a:r>
-            <a:endParaRPr lang="en-US" sz="4400" dirty="0"/>
-          </a:p>
-        </p:txBody>
-      </p:sp>
-      <p:sp>
-        <p:nvSpPr>
-          <p:cNvPr id="4" name="Text 2"/>
-          <p:cNvSpPr/>
-          <p:nvPr/>
-        </p:nvSpPr>
-        <p:spPr>
-          <a:xfrm>
-            <a:off x="2926080" y="3749040"/>
-            <a:ext cx="6400800" cy="365760"/>
-          </a:xfrm>
-          <a:prstGeom prst="rect">
-            <a:avLst/>
-          </a:prstGeom>
-          <a:noFill/>
-          <a:ln/>
-        </p:spPr>
-        <p:txBody>
-          <a:bodyPr wrap="square" rtlCol="0" anchor="ctr"/>
-          <a:lstStyle/>
-          <a:p>
-            <a:pPr algn="ctr" indent="0" marL="0">
-              <a:buNone/>
-            </a:pPr>
-            <a:r>
-              <a:rPr lang="en-US" sz="1700" dirty="0">
-                <a:solidFill>
-                  <a:srgbClr val="FFDE59"/>
-                </a:solidFill>
-              </a:rPr>
-              <a:t>only if everyone actually votes and no one flakes.</a:t>
-            </a:r>
-            <a:endParaRPr lang="en-US" sz="1700" dirty="0"/>
+              <a:t>only if people answer the group chat like adults</a:t>
+            </a:r>
+            <a:endParaRPr lang="en-US" sz="1800" dirty="0"/>
           </a:p>
         </p:txBody>
       </p:sp>
@@ -2491,8 +2370,8 @@
         </p:nvSpPr>
         <p:spPr>
           <a:xfrm>
-            <a:off x="502920" y="384048"/>
-            <a:ext cx="11064240" cy="658368"/>
+            <a:off x="658368" y="429768"/>
+            <a:ext cx="9144000" cy="502920"/>
           </a:xfrm>
           <a:prstGeom prst="rect">
             <a:avLst/>
@@ -2508,9 +2387,9 @@
               <a:buNone/>
             </a:pPr>
             <a:r>
-              <a:rPr lang="en-US" sz="3000" b="1" dirty="0">
+              <a:rPr lang="en-US" sz="2900" b="1" dirty="0">
                 <a:solidFill>
-                  <a:srgbClr val="2B1B3D"/>
+                  <a:srgbClr val="1C3238"/>
                 </a:solidFill>
                 <a:latin typeface="Aptos Display" pitchFamily="34" charset="0"/>
                 <a:ea typeface="Aptos Display" pitchFamily="34" charset="-122"/>
@@ -2518,7 +2397,7 @@
               </a:rPr>
               <a:t>the extremely serious food math</a:t>
             </a:r>
-            <a:endParaRPr lang="en-US" sz="3000" dirty="0"/>
+            <a:endParaRPr lang="en-US" sz="2900" dirty="0"/>
           </a:p>
         </p:txBody>
       </p:sp>
@@ -2530,8 +2409,8 @@
         </p:nvSpPr>
         <p:spPr>
           <a:xfrm>
-            <a:off x="685800" y="1234440"/>
-            <a:ext cx="6492240" cy="4297680"/>
+            <a:off x="713232" y="1261872"/>
+            <a:ext cx="4800600" cy="3931920"/>
           </a:xfrm>
           <a:prstGeom prst="rect">
             <a:avLst/>
@@ -2540,133 +2419,157 @@
           <a:ln/>
         </p:spPr>
         <p:txBody>
-          <a:bodyPr wrap="square" rtlCol="0" anchor="ctr"/>
+          <a:bodyPr wrap="square" lIns="0" tIns="0" rIns="0" bIns="0" rtlCol="0" anchor="ctr"/>
           <a:lstStyle/>
           <a:p>
             <a:pPr indent="0" marL="0">
               <a:buNone/>
             </a:pPr>
             <a:r>
-              <a:rPr lang="en-US" sz="2000" dirty="0">
+              <a:rPr lang="en-US" sz="2200" dirty="0">
                 <a:solidFill>
-                  <a:srgbClr val="000000"/>
+                  <a:srgbClr val="33454B"/>
                 </a:solidFill>
+                <a:latin typeface="Aptos" pitchFamily="34" charset="0"/>
+                <a:ea typeface="Aptos" pitchFamily="34" charset="-122"/>
+                <a:cs typeface="Aptos" pitchFamily="34" charset="-120"/>
               </a:rPr>
-              <a:t>Maré Baixa: €€€</a:t>
-            </a:r>
-            <a:endParaRPr lang="en-US" sz="2000" dirty="0"/>
+              <a:t>maré baixa</a:t>
+            </a:r>
+            <a:endParaRPr lang="en-US" sz="2200" dirty="0"/>
           </a:p>
           <a:p>
             <a:pPr indent="0" marL="0">
               <a:buNone/>
             </a:pPr>
             <a:r>
-              <a:rPr lang="en-US" sz="2000" dirty="0">
+              <a:rPr lang="en-US" sz="2200" dirty="0">
                 <a:solidFill>
-                  <a:srgbClr val="000000"/>
+                  <a:srgbClr val="33454B"/>
                 </a:solidFill>
+                <a:latin typeface="Aptos" pitchFamily="34" charset="0"/>
+                <a:ea typeface="Aptos" pitchFamily="34" charset="-122"/>
+                <a:cs typeface="Aptos" pitchFamily="34" charset="-120"/>
               </a:rPr>
-              <a:t>first-night table / book it</a:t>
-            </a:r>
-            <a:endParaRPr lang="en-US" sz="2000" dirty="0"/>
+              <a:t>first night. book it.</a:t>
+            </a:r>
+            <a:endParaRPr lang="en-US" sz="2200" dirty="0"/>
           </a:p>
           <a:p>
             <a:pPr indent="0" marL="0">
               <a:buNone/>
             </a:pPr>
-            <a:endParaRPr lang="en-US" sz="2000" dirty="0"/>
+            <a:endParaRPr lang="en-US" sz="2200" dirty="0"/>
           </a:p>
           <a:p>
             <a:pPr indent="0" marL="0">
               <a:buNone/>
             </a:pPr>
             <a:r>
-              <a:rPr lang="en-US" sz="2000" dirty="0">
+              <a:rPr lang="en-US" sz="2200" dirty="0">
                 <a:solidFill>
-                  <a:srgbClr val="000000"/>
+                  <a:srgbClr val="33454B"/>
                 </a:solidFill>
+                <a:latin typeface="Aptos" pitchFamily="34" charset="0"/>
+                <a:ea typeface="Aptos" pitchFamily="34" charset="-122"/>
+                <a:cs typeface="Aptos" pitchFamily="34" charset="-120"/>
               </a:rPr>
-              <a:t>pastel situation: non-negotiable</a:t>
-            </a:r>
-            <a:endParaRPr lang="en-US" sz="2000" dirty="0"/>
+              <a:t>pastel situation</a:t>
+            </a:r>
+            <a:endParaRPr lang="en-US" sz="2200" dirty="0"/>
           </a:p>
           <a:p>
             <a:pPr indent="0" marL="0">
               <a:buNone/>
             </a:pPr>
-            <a:endParaRPr lang="en-US" sz="2000" dirty="0"/>
+            <a:r>
+              <a:rPr lang="en-US" sz="2200" dirty="0">
+                <a:solidFill>
+                  <a:srgbClr val="33454B"/>
+                </a:solidFill>
+                <a:latin typeface="Aptos" pitchFamily="34" charset="0"/>
+                <a:ea typeface="Aptos" pitchFamily="34" charset="-122"/>
+                <a:cs typeface="Aptos" pitchFamily="34" charset="-120"/>
+              </a:rPr>
+              <a:t>non-negotiable.</a:t>
+            </a:r>
+            <a:endParaRPr lang="en-US" sz="2200" dirty="0"/>
           </a:p>
           <a:p>
             <a:pPr indent="0" marL="0">
               <a:buNone/>
             </a:pPr>
-            <a:r>
-              <a:rPr lang="en-US" sz="2000" dirty="0">
+            <a:endParaRPr lang="en-US" sz="2200" dirty="0"/>
+          </a:p>
+          <a:p>
+            <a:pPr indent="0" marL="0">
+              <a:buNone/>
+            </a:pPr>
+            <a:r>
+              <a:rPr lang="en-US" sz="2200" dirty="0">
                 <a:solidFill>
-                  <a:srgbClr val="000000"/>
+                  <a:srgbClr val="33454B"/>
                 </a:solidFill>
+                <a:latin typeface="Aptos" pitchFamily="34" charset="0"/>
+                <a:ea typeface="Aptos" pitchFamily="34" charset="-122"/>
+                <a:cs typeface="Aptos" pitchFamily="34" charset="-120"/>
               </a:rPr>
-              <a:t>last dinner: TBD bc dev wants ‘an actual budget’ which is rude but fair</a:t>
-            </a:r>
-            <a:endParaRPr lang="en-US" sz="2000" dirty="0"/>
+              <a:t>last dinner</a:t>
+            </a:r>
+            <a:endParaRPr lang="en-US" sz="2200" dirty="0"/>
           </a:p>
           <a:p>
             <a:pPr indent="0" marL="0">
               <a:buNone/>
             </a:pPr>
-            <a:endParaRPr lang="en-US" sz="2000" dirty="0"/>
-          </a:p>
-          <a:p>
-            <a:pPr indent="0" marL="0">
-              <a:buNone/>
-            </a:pPr>
-            <a:r>
-              <a:rPr lang="en-US" sz="2000" dirty="0">
+            <a:r>
+              <a:rPr lang="en-US" sz="2200" dirty="0">
                 <a:solidFill>
-                  <a:srgbClr val="000000"/>
+                  <a:srgbClr val="33454B"/>
                 </a:solidFill>
+                <a:latin typeface="Aptos" pitchFamily="34" charset="0"/>
+                <a:ea typeface="Aptos" pitchFamily="34" charset="-122"/>
+                <a:cs typeface="Aptos" pitchFamily="34" charset="-120"/>
               </a:rPr>
-              <a:t>also i found three bakeries but maya said no more tabs</a:t>
-            </a:r>
-            <a:endParaRPr lang="en-US" sz="2000" dirty="0"/>
-          </a:p>
-        </p:txBody>
-      </p:sp>
-      <p:sp>
-        <p:nvSpPr>
-          <p:cNvPr id="4" name="Shape 2"/>
-          <p:cNvSpPr/>
+              <a:t>TBD because dev wants an “actual budget”</a:t>
+            </a:r>
+            <a:endParaRPr lang="en-US" sz="2200" dirty="0"/>
+          </a:p>
+        </p:txBody>
+      </p:sp>
+      <p:pic>
+        <p:nvPicPr>
+          <p:cNvPr id="4" name="Image 0" descr="C:\Users\gusing\.copilot\chats\2026-09-18\ubiquitous-parakeet-7374a405\images-pexels\portuguese-food-1.jpg">    </p:cNvPr>
+          <p:cNvPicPr>
+            <a:picLocks noChangeAspect="1"/>
+          </p:cNvPicPr>
           <p:nvPr/>
-        </p:nvSpPr>
+        </p:nvPicPr>
+        <p:blipFill>
+          <a:blip r:embed="rId1"/>
+          <a:srcRect l="0" r="0" t="0" b="0"/>
+          <a:stretch/>
+        </p:blipFill>
         <p:spPr>
           <a:xfrm>
-            <a:off x="7635240" y="1325880"/>
-            <a:ext cx="3246120" cy="3246120"/>
+            <a:off x="6629400" y="1225296"/>
+            <a:ext cx="3520440" cy="3566160"/>
           </a:xfrm>
           <a:prstGeom prst="rect">
             <a:avLst/>
           </a:prstGeom>
-          <a:solidFill>
-            <a:srgbClr val="FFE66D"/>
-          </a:solidFill>
-          <a:ln w="25400">
-            <a:solidFill>
-              <a:srgbClr val="E6B800"/>
-            </a:solidFill>
-            <a:prstDash val="solid"/>
-          </a:ln>
         </p:spPr>
-      </p:sp>
-      <p:sp>
-        <p:nvSpPr>
-          <p:cNvPr id="5" name="Text 3"/>
+      </p:pic>
+      <p:sp>
+        <p:nvSpPr>
+          <p:cNvPr id="5" name="Text 2"/>
           <p:cNvSpPr/>
           <p:nvPr/>
         </p:nvSpPr>
         <p:spPr>
           <a:xfrm>
-            <a:off x="7955280" y="1874520"/>
-            <a:ext cx="2606040" cy="1371600"/>
+            <a:off x="7589520" y="4224528"/>
+            <a:ext cx="1645920" cy="365760"/>
           </a:xfrm>
           <a:prstGeom prst="rect">
             <a:avLst/>
@@ -2675,75 +2578,24 @@
           <a:ln/>
         </p:spPr>
         <p:txBody>
-          <a:bodyPr wrap="square" rtlCol="0" anchor="ctr"/>
-          <a:lstStyle/>
-          <a:p>
-            <a:pPr algn="ctr" indent="0" marL="0">
-              <a:buNone/>
-            </a:pPr>
-            <a:r>
-              <a:rPr lang="en-US" sz="1800" b="1" dirty="0">
+          <a:bodyPr wrap="square" lIns="0" tIns="0" rIns="0" bIns="0" rtlCol="0" anchor="ctr"/>
+          <a:lstStyle/>
+          <a:p>
+            <a:pPr indent="0" marL="0">
+              <a:buNone/>
+            </a:pPr>
+            <a:r>
+              <a:rPr lang="en-US" sz="2400" b="1" dirty="0">
                 <a:solidFill>
-                  <a:srgbClr val="6C5300"/>
+                  <a:srgbClr val="E91E63"/>
                 </a:solidFill>
+                <a:latin typeface="Comic Sans MS" pitchFamily="34" charset="0"/>
+                <a:ea typeface="Comic Sans MS" pitchFamily="34" charset="-122"/>
+                <a:cs typeface="Comic Sans MS" pitchFamily="34" charset="-120"/>
               </a:rPr>
-              <a:t>THIS 😭</a:t>
-            </a:r>
-            <a:endParaRPr lang="en-US" sz="1800" dirty="0"/>
-          </a:p>
-          <a:p>
-            <a:pPr algn="ctr" indent="0" marL="0">
-              <a:buNone/>
-            </a:pPr>
-            <a:endParaRPr lang="en-US" sz="1800" dirty="0"/>
-          </a:p>
-          <a:p>
-            <a:pPr algn="ctr" indent="0" marL="0">
-              <a:buNone/>
-            </a:pPr>
-            <a:r>
-              <a:rPr lang="en-US" sz="1800" b="1" dirty="0">
-                <a:solidFill>
-                  <a:srgbClr val="6C5300"/>
-                </a:solidFill>
-              </a:rPr>
-              <a:t>[pasted menu</a:t>
-            </a:r>
-            <a:endParaRPr lang="en-US" sz="1800" dirty="0"/>
-          </a:p>
-          <a:p>
-            <a:pPr algn="ctr" indent="0" marL="0">
-              <a:buNone/>
-            </a:pPr>
-            <a:r>
-              <a:rPr lang="en-US" sz="1800" b="1" dirty="0">
-                <a:solidFill>
-                  <a:srgbClr val="6C5300"/>
-                </a:solidFill>
-              </a:rPr>
-              <a:t>screenshot]</a:t>
-            </a:r>
-            <a:endParaRPr lang="en-US" sz="1800" dirty="0"/>
-          </a:p>
-          <a:p>
-            <a:pPr algn="ctr" indent="0" marL="0">
-              <a:buNone/>
-            </a:pPr>
-            <a:endParaRPr lang="en-US" sz="1800" dirty="0"/>
-          </a:p>
-          <a:p>
-            <a:pPr algn="ctr" indent="0" marL="0">
-              <a:buNone/>
-            </a:pPr>
-            <a:r>
-              <a:rPr lang="en-US" sz="1800" b="1" dirty="0">
-                <a:solidFill>
-                  <a:srgbClr val="6C5300"/>
-                </a:solidFill>
-              </a:rPr>
-              <a:t>arroz de marisco</a:t>
-            </a:r>
-            <a:endParaRPr lang="en-US" sz="1800" dirty="0"/>
+              <a:t>THIS</a:t>
+            </a:r>
+            <a:endParaRPr lang="en-US" sz="2400" dirty="0"/>
           </a:p>
         </p:txBody>
       </p:sp>
@@ -2787,8 +2639,8 @@
         </p:nvSpPr>
         <p:spPr>
           <a:xfrm>
-            <a:off x="1097280" y="2240280"/>
-            <a:ext cx="9966960" cy="1005840"/>
+            <a:off x="1051560" y="2240280"/>
+            <a:ext cx="9875520" cy="822960"/>
           </a:xfrm>
           <a:prstGeom prst="rect">
             <a:avLst/>
@@ -2797,14 +2649,14 @@
           <a:ln/>
         </p:spPr>
         <p:txBody>
-          <a:bodyPr wrap="square" rtlCol="0" anchor="ctr"/>
+          <a:bodyPr wrap="square" lIns="0" tIns="0" rIns="0" bIns="0" rtlCol="0" anchor="ctr"/>
           <a:lstStyle/>
           <a:p>
             <a:pPr algn="ctr" indent="0" marL="0">
               <a:buNone/>
             </a:pPr>
             <a:r>
-              <a:rPr lang="en-US" sz="4800" b="1" dirty="0">
+              <a:rPr lang="en-US" sz="5000" b="1" dirty="0">
                 <a:solidFill>
                   <a:srgbClr val="FFFFFF"/>
                 </a:solidFill>
@@ -2814,7 +2666,7 @@
               </a:rPr>
               <a:t>vote in the gc</a:t>
             </a:r>
-            <a:endParaRPr lang="en-US" sz="4800" dirty="0"/>
+            <a:endParaRPr lang="en-US" sz="5000" dirty="0"/>
           </a:p>
         </p:txBody>
       </p:sp>
@@ -2869,7 +2721,7 @@
     </a:clrScheme>
     <a:fontScheme name="Office">
       <a:majorFont>
-        <a:latin typeface="Aptos Display"/>
+        <a:latin typeface="Calibri Light" panose="020F0302020204030204"/>
         <a:ea typeface=""/>
         <a:cs typeface=""/>
         <a:font script="Jpan" typeface="游ゴシック Light"/>
@@ -2921,7 +2773,7 @@
         <a:font script="Tfng" typeface="Ebrima"/>
       </a:majorFont>
       <a:minorFont>
-        <a:latin typeface="Aptos"/>
+        <a:latin typeface="Calibri" panose="020F0502020204030204"/>
         <a:ea typeface=""/>
         <a:cs typeface=""/>
         <a:font script="Jpan" typeface="游ゴシック"/>

</xml_diff>